<commit_message>
deliverables: fix North Star deck layout (slide 5 chevron labels, slide 12 badge)
- Slide 5: pipeline chevron labels now horizontal/centered inside each chevron
  (inset past the chevron's concave notch); no more vertical letter-stacking or
  overflow into the So-what strip / bottom callout.
- Slide 12: '* PROTAGONIST' badge moved to its own line; long names (Khumalo,
  Dlamini) render in full with no overlap.
Verified via LibreOffice render of all affected slides; 23 slides, QA clean.

https://claude.ai/code/session_01Y1BzmdqaFpcwQGxnGiMwG5
</commit_message>
<xml_diff>
--- a/deliverables/06-future-state-northstar-deck.pptx
+++ b/deliverables/06-future-state-northstar-deck.pptx
@@ -8870,7 +8870,7 @@
         </p:nvSpPr>
         <p:spPr>
           <a:xfrm>
-            <a:off x="1554480" y="2450592"/>
+            <a:off x="1554480" y="2414016"/>
             <a:ext cx="2423160" cy="365760"/>
           </a:xfrm>
           <a:prstGeom prst="rect">
@@ -8890,7 +8890,7 @@
               </a:lnSpc>
             </a:pPr>
             <a:r>
-              <a:rPr sz="1350" b="1" i="0" u="none">
+              <a:rPr sz="1300" b="1" i="0" u="none">
                 <a:solidFill>
                   <a:srgbClr val="1D1D1D"/>
                 </a:solidFill>
@@ -8909,7 +8909,7 @@
         </p:nvSpPr>
         <p:spPr>
           <a:xfrm>
-            <a:off x="1554480" y="2798064"/>
+            <a:off x="1554480" y="2761488"/>
             <a:ext cx="2423160" cy="274320"/>
           </a:xfrm>
           <a:prstGeom prst="rect">
@@ -8948,8 +8948,8 @@
         </p:nvSpPr>
         <p:spPr>
           <a:xfrm>
-            <a:off x="804672" y="3273552"/>
-            <a:ext cx="3099816" cy="1143000"/>
+            <a:off x="804672" y="3383280"/>
+            <a:ext cx="3099816" cy="1097280"/>
           </a:xfrm>
           <a:prstGeom prst="rect">
             <a:avLst/>
@@ -8987,8 +8987,8 @@
         </p:nvSpPr>
         <p:spPr>
           <a:xfrm>
-            <a:off x="2926080" y="2286000"/>
-            <a:ext cx="1097280" cy="274320"/>
+            <a:off x="1554480" y="3054096"/>
+            <a:ext cx="1143000" cy="256032"/>
           </a:xfrm>
           <a:prstGeom prst="roundRect">
             <a:avLst/>
@@ -9157,7 +9157,7 @@
         </p:nvSpPr>
         <p:spPr>
           <a:xfrm>
-            <a:off x="5294376" y="2450592"/>
+            <a:off x="5294376" y="2414016"/>
             <a:ext cx="2423160" cy="365760"/>
           </a:xfrm>
           <a:prstGeom prst="rect">
@@ -9177,7 +9177,7 @@
               </a:lnSpc>
             </a:pPr>
             <a:r>
-              <a:rPr sz="1350" b="1" i="0" u="none">
+              <a:rPr sz="1300" b="1" i="0" u="none">
                 <a:solidFill>
                   <a:srgbClr val="1D1D1D"/>
                 </a:solidFill>
@@ -9196,7 +9196,7 @@
         </p:nvSpPr>
         <p:spPr>
           <a:xfrm>
-            <a:off x="5294376" y="2798064"/>
+            <a:off x="5294376" y="2761488"/>
             <a:ext cx="2423160" cy="274320"/>
           </a:xfrm>
           <a:prstGeom prst="rect">
@@ -9235,8 +9235,8 @@
         </p:nvSpPr>
         <p:spPr>
           <a:xfrm>
-            <a:off x="4544568" y="3273552"/>
-            <a:ext cx="3099816" cy="1143000"/>
+            <a:off x="4544568" y="3383280"/>
+            <a:ext cx="3099816" cy="1097280"/>
           </a:xfrm>
           <a:prstGeom prst="rect">
             <a:avLst/>
@@ -9274,8 +9274,8 @@
         </p:nvSpPr>
         <p:spPr>
           <a:xfrm>
-            <a:off x="6665976" y="2286000"/>
-            <a:ext cx="1097280" cy="274320"/>
+            <a:off x="5294376" y="3054096"/>
+            <a:ext cx="1143000" cy="256032"/>
           </a:xfrm>
           <a:prstGeom prst="roundRect">
             <a:avLst/>
@@ -9444,7 +9444,7 @@
         </p:nvSpPr>
         <p:spPr>
           <a:xfrm>
-            <a:off x="9034272" y="2450592"/>
+            <a:off x="9034272" y="2414016"/>
             <a:ext cx="2423160" cy="365760"/>
           </a:xfrm>
           <a:prstGeom prst="rect">
@@ -9464,7 +9464,7 @@
               </a:lnSpc>
             </a:pPr>
             <a:r>
-              <a:rPr sz="1350" b="1" i="0" u="none">
+              <a:rPr sz="1300" b="1" i="0" u="none">
                 <a:solidFill>
                   <a:srgbClr val="1D1D1D"/>
                 </a:solidFill>
@@ -9483,7 +9483,7 @@
         </p:nvSpPr>
         <p:spPr>
           <a:xfrm>
-            <a:off x="9034272" y="2798064"/>
+            <a:off x="9034272" y="2761488"/>
             <a:ext cx="2423160" cy="274320"/>
           </a:xfrm>
           <a:prstGeom prst="rect">
@@ -9522,8 +9522,8 @@
         </p:nvSpPr>
         <p:spPr>
           <a:xfrm>
-            <a:off x="8284464" y="3273552"/>
-            <a:ext cx="3099816" cy="1143000"/>
+            <a:off x="8284464" y="3383280"/>
+            <a:ext cx="3099816" cy="1097280"/>
           </a:xfrm>
           <a:prstGeom prst="rect">
             <a:avLst/>
@@ -9561,8 +9561,8 @@
         </p:nvSpPr>
         <p:spPr>
           <a:xfrm>
-            <a:off x="10405872" y="2286000"/>
-            <a:ext cx="1097280" cy="274320"/>
+            <a:off x="9034272" y="3054096"/>
+            <a:ext cx="1143000" cy="256032"/>
           </a:xfrm>
           <a:prstGeom prst="roundRect">
             <a:avLst/>
@@ -26511,25 +26511,10 @@
           </a:fontRef>
         </p:style>
         <p:txBody>
-          <a:bodyPr rtlCol="0" anchor="ctr" wrap="square" lIns="45720" rIns="45720" tIns="27432" bIns="27432">
-            <a:noAutofit/>
-          </a:bodyPr>
-          <a:lstStyle/>
-          <a:p>
-            <a:pPr algn="ctr">
-              <a:lnSpc>
-                <a:spcPct val="100000"/>
-              </a:lnSpc>
-            </a:pPr>
-            <a:r>
-              <a:rPr sz="1250" b="1" i="0">
-                <a:solidFill>
-                  <a:srgbClr val="1D1D1D"/>
-                </a:solidFill>
-                <a:latin typeface="Calibri"/>
-              </a:rPr>
-              <a:t>Research</a:t>
-            </a:r>
+          <a:bodyPr rtlCol="0" anchor="ctr"/>
+          <a:lstStyle/>
+          <a:p>
+            <a:pPr algn="ctr"/>
           </a:p>
         </p:txBody>
       </p:sp>
@@ -26541,6 +26526,45 @@
         </p:nvSpPr>
         <p:spPr>
           <a:xfrm>
+            <a:off x="1798167" y="2606040"/>
+            <a:ext cx="822960" cy="1371600"/>
+          </a:xfrm>
+          <a:prstGeom prst="rect">
+            <a:avLst/>
+          </a:prstGeom>
+          <a:noFill/>
+        </p:spPr>
+        <p:txBody>
+          <a:bodyPr wrap="square" anchor="ctr" lIns="0" rIns="0" tIns="0" bIns="0">
+            <a:noAutofit/>
+          </a:bodyPr>
+          <a:lstStyle/>
+          <a:p>
+            <a:pPr algn="ctr">
+              <a:lnSpc>
+                <a:spcPct val="98000"/>
+              </a:lnSpc>
+            </a:pPr>
+            <a:r>
+              <a:rPr sz="1050" b="1" i="0" u="none">
+                <a:solidFill>
+                  <a:srgbClr val="1D1D1D"/>
+                </a:solidFill>
+                <a:latin typeface="Calibri"/>
+              </a:rPr>
+              <a:t>Research</a:t>
+            </a:r>
+          </a:p>
+        </p:txBody>
+      </p:sp>
+      <p:sp>
+        <p:nvSpPr>
+          <p:cNvPr id="14" name="TextBox 13"/>
+          <p:cNvSpPr txBox="1"/>
+          <p:nvPr/>
+        </p:nvSpPr>
+        <p:spPr>
+          <a:xfrm>
             <a:off x="1176375" y="4069080"/>
             <a:ext cx="1389888" cy="640080"/>
           </a:xfrm>
@@ -26590,7 +26614,7 @@
       </p:sp>
       <p:sp>
         <p:nvSpPr>
-          <p:cNvPr id="14" name="Chevron 13"/>
+          <p:cNvPr id="15" name="Chevron 14"/>
           <p:cNvSpPr/>
           <p:nvPr/>
         </p:nvSpPr>
@@ -26625,31 +26649,71 @@
           </a:fontRef>
         </p:style>
         <p:txBody>
-          <a:bodyPr rtlCol="0" anchor="ctr" wrap="square" lIns="45720" rIns="45720" tIns="27432" bIns="27432">
+          <a:bodyPr rtlCol="0" anchor="ctr"/>
+          <a:lstStyle/>
+          <a:p>
+            <a:pPr algn="ctr"/>
+          </a:p>
+        </p:txBody>
+      </p:sp>
+      <p:sp>
+        <p:nvSpPr>
+          <p:cNvPr id="16" name="TextBox 15"/>
+          <p:cNvSpPr txBox="1"/>
+          <p:nvPr/>
+        </p:nvSpPr>
+        <p:spPr>
+          <a:xfrm>
+            <a:off x="3206343" y="2606040"/>
+            <a:ext cx="822960" cy="1371600"/>
+          </a:xfrm>
+          <a:prstGeom prst="rect">
+            <a:avLst/>
+          </a:prstGeom>
+          <a:noFill/>
+        </p:spPr>
+        <p:txBody>
+          <a:bodyPr wrap="square" anchor="ctr" lIns="0" rIns="0" tIns="0" bIns="0">
             <a:noAutofit/>
           </a:bodyPr>
           <a:lstStyle/>
           <a:p>
             <a:pPr algn="ctr">
               <a:lnSpc>
-                <a:spcPct val="100000"/>
-              </a:lnSpc>
-            </a:pPr>
-            <a:r>
-              <a:rPr sz="1250" b="1" i="0">
+                <a:spcPct val="98000"/>
+              </a:lnSpc>
+            </a:pPr>
+            <a:r>
+              <a:rPr sz="1050" b="1" i="0" u="none">
                 <a:solidFill>
                   <a:srgbClr val="1D1D1D"/>
                 </a:solidFill>
                 <a:latin typeface="Calibri"/>
               </a:rPr>
-              <a:t>Best practice</a:t>
-            </a:r>
-          </a:p>
-        </p:txBody>
-      </p:sp>
-      <p:sp>
-        <p:nvSpPr>
-          <p:cNvPr id="15" name="TextBox 14"/>
+              <a:t>Best</a:t>
+            </a:r>
+          </a:p>
+          <a:p>
+            <a:pPr algn="ctr">
+              <a:lnSpc>
+                <a:spcPct val="98000"/>
+              </a:lnSpc>
+            </a:pPr>
+            <a:r>
+              <a:rPr sz="1050" b="1" i="0" u="none">
+                <a:solidFill>
+                  <a:srgbClr val="1D1D1D"/>
+                </a:solidFill>
+                <a:latin typeface="Calibri"/>
+              </a:rPr>
+              <a:t>practice</a:t>
+            </a:r>
+          </a:p>
+        </p:txBody>
+      </p:sp>
+      <p:sp>
+        <p:nvSpPr>
+          <p:cNvPr id="17" name="TextBox 16"/>
           <p:cNvSpPr txBox="1"/>
           <p:nvPr/>
         </p:nvSpPr>
@@ -26704,7 +26768,7 @@
       </p:sp>
       <p:sp>
         <p:nvSpPr>
-          <p:cNvPr id="16" name="Chevron 15"/>
+          <p:cNvPr id="18" name="Chevron 17"/>
           <p:cNvSpPr/>
           <p:nvPr/>
         </p:nvSpPr>
@@ -26739,32 +26803,71 @@
           </a:fontRef>
         </p:style>
         <p:txBody>
-          <a:bodyPr rtlCol="0" anchor="ctr" wrap="square" lIns="45720" rIns="45720" tIns="27432" bIns="27432">
+          <a:bodyPr rtlCol="0" anchor="ctr"/>
+          <a:lstStyle/>
+          <a:p>
+            <a:pPr algn="ctr"/>
+          </a:p>
+        </p:txBody>
+      </p:sp>
+      <p:sp>
+        <p:nvSpPr>
+          <p:cNvPr id="19" name="TextBox 18"/>
+          <p:cNvSpPr txBox="1"/>
+          <p:nvPr/>
+        </p:nvSpPr>
+        <p:spPr>
+          <a:xfrm>
+            <a:off x="4614519" y="2606040"/>
+            <a:ext cx="822960" cy="1371600"/>
+          </a:xfrm>
+          <a:prstGeom prst="rect">
+            <a:avLst/>
+          </a:prstGeom>
+          <a:noFill/>
+        </p:spPr>
+        <p:txBody>
+          <a:bodyPr wrap="square" anchor="ctr" lIns="0" rIns="0" tIns="0" bIns="0">
             <a:noAutofit/>
           </a:bodyPr>
           <a:lstStyle/>
           <a:p>
             <a:pPr algn="ctr">
               <a:lnSpc>
-                <a:spcPct val="100000"/>
-              </a:lnSpc>
-            </a:pPr>
-            <a:r>
-              <a:rPr sz="1250" b="1" i="0">
+                <a:spcPct val="98000"/>
+              </a:lnSpc>
+            </a:pPr>
+            <a:r>
+              <a:rPr sz="1050" b="1" i="0" u="none">
                 <a:solidFill>
                   <a:srgbClr val="1D1D1D"/>
                 </a:solidFill>
                 <a:latin typeface="Calibri"/>
               </a:rPr>
-              <a:t>Strategic
-principles</a:t>
-            </a:r>
-          </a:p>
-        </p:txBody>
-      </p:sp>
-      <p:sp>
-        <p:nvSpPr>
-          <p:cNvPr id="17" name="TextBox 16"/>
+              <a:t>Strategic</a:t>
+            </a:r>
+          </a:p>
+          <a:p>
+            <a:pPr algn="ctr">
+              <a:lnSpc>
+                <a:spcPct val="98000"/>
+              </a:lnSpc>
+            </a:pPr>
+            <a:r>
+              <a:rPr sz="1050" b="1" i="0" u="none">
+                <a:solidFill>
+                  <a:srgbClr val="1D1D1D"/>
+                </a:solidFill>
+                <a:latin typeface="Calibri"/>
+              </a:rPr>
+              <a:t>principles</a:t>
+            </a:r>
+          </a:p>
+        </p:txBody>
+      </p:sp>
+      <p:sp>
+        <p:nvSpPr>
+          <p:cNvPr id="20" name="TextBox 19"/>
           <p:cNvSpPr txBox="1"/>
           <p:nvPr/>
         </p:nvSpPr>
@@ -26819,7 +26922,7 @@
       </p:sp>
       <p:sp>
         <p:nvSpPr>
-          <p:cNvPr id="18" name="Chevron 17"/>
+          <p:cNvPr id="21" name="Chevron 20"/>
           <p:cNvSpPr/>
           <p:nvPr/>
         </p:nvSpPr>
@@ -26854,32 +26957,71 @@
           </a:fontRef>
         </p:style>
         <p:txBody>
-          <a:bodyPr rtlCol="0" anchor="ctr" wrap="square" lIns="45720" rIns="45720" tIns="27432" bIns="27432">
+          <a:bodyPr rtlCol="0" anchor="ctr"/>
+          <a:lstStyle/>
+          <a:p>
+            <a:pPr algn="ctr"/>
+          </a:p>
+        </p:txBody>
+      </p:sp>
+      <p:sp>
+        <p:nvSpPr>
+          <p:cNvPr id="22" name="TextBox 21"/>
+          <p:cNvSpPr txBox="1"/>
+          <p:nvPr/>
+        </p:nvSpPr>
+        <p:spPr>
+          <a:xfrm>
+            <a:off x="6022695" y="2606040"/>
+            <a:ext cx="822960" cy="1371600"/>
+          </a:xfrm>
+          <a:prstGeom prst="rect">
+            <a:avLst/>
+          </a:prstGeom>
+          <a:noFill/>
+        </p:spPr>
+        <p:txBody>
+          <a:bodyPr wrap="square" anchor="ctr" lIns="0" rIns="0" tIns="0" bIns="0">
             <a:noAutofit/>
           </a:bodyPr>
           <a:lstStyle/>
           <a:p>
             <a:pPr algn="ctr">
               <a:lnSpc>
-                <a:spcPct val="100000"/>
-              </a:lnSpc>
-            </a:pPr>
-            <a:r>
-              <a:rPr sz="1250" b="1" i="0">
+                <a:spcPct val="98000"/>
+              </a:lnSpc>
+            </a:pPr>
+            <a:r>
+              <a:rPr sz="1050" b="1" i="0" u="none">
                 <a:solidFill>
                   <a:srgbClr val="1D1D1D"/>
                 </a:solidFill>
                 <a:latin typeface="Calibri"/>
               </a:rPr>
-              <a:t>UX
-principles</a:t>
-            </a:r>
-          </a:p>
-        </p:txBody>
-      </p:sp>
-      <p:sp>
-        <p:nvSpPr>
-          <p:cNvPr id="19" name="TextBox 18"/>
+              <a:t>UX</a:t>
+            </a:r>
+          </a:p>
+          <a:p>
+            <a:pPr algn="ctr">
+              <a:lnSpc>
+                <a:spcPct val="98000"/>
+              </a:lnSpc>
+            </a:pPr>
+            <a:r>
+              <a:rPr sz="1050" b="1" i="0" u="none">
+                <a:solidFill>
+                  <a:srgbClr val="1D1D1D"/>
+                </a:solidFill>
+                <a:latin typeface="Calibri"/>
+              </a:rPr>
+              <a:t>principles</a:t>
+            </a:r>
+          </a:p>
+        </p:txBody>
+      </p:sp>
+      <p:sp>
+        <p:nvSpPr>
+          <p:cNvPr id="23" name="TextBox 22"/>
           <p:cNvSpPr txBox="1"/>
           <p:nvPr/>
         </p:nvSpPr>
@@ -26934,7 +27076,7 @@
       </p:sp>
       <p:sp>
         <p:nvSpPr>
-          <p:cNvPr id="20" name="Chevron 19"/>
+          <p:cNvPr id="24" name="Chevron 23"/>
           <p:cNvSpPr/>
           <p:nvPr/>
         </p:nvSpPr>
@@ -26969,18 +27111,42 @@
           </a:fontRef>
         </p:style>
         <p:txBody>
-          <a:bodyPr rtlCol="0" anchor="ctr" wrap="square" lIns="45720" rIns="45720" tIns="27432" bIns="27432">
+          <a:bodyPr rtlCol="0" anchor="ctr"/>
+          <a:lstStyle/>
+          <a:p>
+            <a:pPr algn="ctr"/>
+          </a:p>
+        </p:txBody>
+      </p:sp>
+      <p:sp>
+        <p:nvSpPr>
+          <p:cNvPr id="25" name="TextBox 24"/>
+          <p:cNvSpPr txBox="1"/>
+          <p:nvPr/>
+        </p:nvSpPr>
+        <p:spPr>
+          <a:xfrm>
+            <a:off x="7430871" y="2606040"/>
+            <a:ext cx="822960" cy="1371600"/>
+          </a:xfrm>
+          <a:prstGeom prst="rect">
+            <a:avLst/>
+          </a:prstGeom>
+          <a:noFill/>
+        </p:spPr>
+        <p:txBody>
+          <a:bodyPr wrap="square" anchor="ctr" lIns="0" rIns="0" tIns="0" bIns="0">
             <a:noAutofit/>
           </a:bodyPr>
           <a:lstStyle/>
           <a:p>
             <a:pPr algn="ctr">
               <a:lnSpc>
-                <a:spcPct val="100000"/>
-              </a:lnSpc>
-            </a:pPr>
-            <a:r>
-              <a:rPr sz="1250" b="1" i="0">
+                <a:spcPct val="98000"/>
+              </a:lnSpc>
+            </a:pPr>
+            <a:r>
+              <a:rPr sz="1050" b="1" i="0" u="none">
                 <a:solidFill>
                   <a:srgbClr val="1D1D1D"/>
                 </a:solidFill>
@@ -26993,7 +27159,7 @@
       </p:sp>
       <p:sp>
         <p:nvSpPr>
-          <p:cNvPr id="21" name="TextBox 20"/>
+          <p:cNvPr id="26" name="TextBox 25"/>
           <p:cNvSpPr txBox="1"/>
           <p:nvPr/>
         </p:nvSpPr>
@@ -27048,7 +27214,7 @@
       </p:sp>
       <p:sp>
         <p:nvSpPr>
-          <p:cNvPr id="22" name="Chevron 21"/>
+          <p:cNvPr id="27" name="Chevron 26"/>
           <p:cNvSpPr/>
           <p:nvPr/>
         </p:nvSpPr>
@@ -27083,18 +27249,42 @@
           </a:fontRef>
         </p:style>
         <p:txBody>
-          <a:bodyPr rtlCol="0" anchor="ctr" wrap="square" lIns="45720" rIns="45720" tIns="27432" bIns="27432">
+          <a:bodyPr rtlCol="0" anchor="ctr"/>
+          <a:lstStyle/>
+          <a:p>
+            <a:pPr algn="ctr"/>
+          </a:p>
+        </p:txBody>
+      </p:sp>
+      <p:sp>
+        <p:nvSpPr>
+          <p:cNvPr id="28" name="TextBox 27"/>
+          <p:cNvSpPr txBox="1"/>
+          <p:nvPr/>
+        </p:nvSpPr>
+        <p:spPr>
+          <a:xfrm>
+            <a:off x="8839047" y="2606040"/>
+            <a:ext cx="822960" cy="1371600"/>
+          </a:xfrm>
+          <a:prstGeom prst="rect">
+            <a:avLst/>
+          </a:prstGeom>
+          <a:noFill/>
+        </p:spPr>
+        <p:txBody>
+          <a:bodyPr wrap="square" anchor="ctr" lIns="0" rIns="0" tIns="0" bIns="0">
             <a:noAutofit/>
           </a:bodyPr>
           <a:lstStyle/>
           <a:p>
             <a:pPr algn="ctr">
               <a:lnSpc>
-                <a:spcPct val="100000"/>
-              </a:lnSpc>
-            </a:pPr>
-            <a:r>
-              <a:rPr sz="1250" b="1" i="0">
+                <a:spcPct val="98000"/>
+              </a:lnSpc>
+            </a:pPr>
+            <a:r>
+              <a:rPr sz="1050" b="1" i="0" u="none">
                 <a:solidFill>
                   <a:srgbClr val="1D1D1D"/>
                 </a:solidFill>
@@ -27107,7 +27297,7 @@
       </p:sp>
       <p:sp>
         <p:nvSpPr>
-          <p:cNvPr id="23" name="TextBox 22"/>
+          <p:cNvPr id="29" name="TextBox 28"/>
           <p:cNvSpPr txBox="1"/>
           <p:nvPr/>
         </p:nvSpPr>
@@ -27162,7 +27352,7 @@
       </p:sp>
       <p:sp>
         <p:nvSpPr>
-          <p:cNvPr id="24" name="Chevron 23"/>
+          <p:cNvPr id="30" name="Chevron 29"/>
           <p:cNvSpPr/>
           <p:nvPr/>
         </p:nvSpPr>
@@ -27203,18 +27393,42 @@
           </a:fontRef>
         </p:style>
         <p:txBody>
-          <a:bodyPr rtlCol="0" anchor="ctr" wrap="square" lIns="45720" rIns="45720" tIns="27432" bIns="27432">
+          <a:bodyPr rtlCol="0" anchor="ctr"/>
+          <a:lstStyle/>
+          <a:p>
+            <a:pPr algn="ctr"/>
+          </a:p>
+        </p:txBody>
+      </p:sp>
+      <p:sp>
+        <p:nvSpPr>
+          <p:cNvPr id="31" name="TextBox 30"/>
+          <p:cNvSpPr txBox="1"/>
+          <p:nvPr/>
+        </p:nvSpPr>
+        <p:spPr>
+          <a:xfrm>
+            <a:off x="10247223" y="2606040"/>
+            <a:ext cx="822960" cy="1371600"/>
+          </a:xfrm>
+          <a:prstGeom prst="rect">
+            <a:avLst/>
+          </a:prstGeom>
+          <a:noFill/>
+        </p:spPr>
+        <p:txBody>
+          <a:bodyPr wrap="square" anchor="ctr" lIns="0" rIns="0" tIns="0" bIns="0">
             <a:noAutofit/>
           </a:bodyPr>
           <a:lstStyle/>
           <a:p>
             <a:pPr algn="ctr">
               <a:lnSpc>
-                <a:spcPct val="100000"/>
-              </a:lnSpc>
-            </a:pPr>
-            <a:r>
-              <a:rPr sz="1250" b="1" i="0">
+                <a:spcPct val="98000"/>
+              </a:lnSpc>
+            </a:pPr>
+            <a:r>
+              <a:rPr sz="1050" b="1" i="0" u="none">
                 <a:solidFill>
                   <a:srgbClr val="FFFFFF"/>
                 </a:solidFill>
@@ -27227,7 +27441,7 @@
       </p:sp>
       <p:sp>
         <p:nvSpPr>
-          <p:cNvPr id="25" name="TextBox 24"/>
+          <p:cNvPr id="32" name="TextBox 31"/>
           <p:cNvSpPr txBox="1"/>
           <p:nvPr/>
         </p:nvSpPr>
@@ -27282,7 +27496,7 @@
       </p:sp>
       <p:sp>
         <p:nvSpPr>
-          <p:cNvPr id="26" name="Rounded Rectangle 25"/>
+          <p:cNvPr id="33" name="Rounded Rectangle 32"/>
           <p:cNvSpPr/>
           <p:nvPr/>
         </p:nvSpPr>

</xml_diff>